<commit_message>
synchronized ppt and pdf, hid microservices
</commit_message>
<xml_diff>
--- a/Slides/Module 11.1 Interaction-Level Design.pptx
+++ b/Slides/Module 11.1 Interaction-Level Design.pptx
@@ -4261,7 +4261,15 @@
             </a:r>
             <a:r>
               <a:rPr lang="en-US" dirty="0"/>
-              <a:t>' at each tick of the clock.</a:t>
+              <a:t>' at each tick of the clock.   You may find this representation familiar from the OOD/Java world, but in the </a:t>
+            </a:r>
+            <a:r>
+              <a:rPr lang="en-US" dirty="0" err="1"/>
+              <a:t>WebAPI</a:t>
+            </a:r>
+            <a:r>
+              <a:rPr lang="en-US" dirty="0"/>
+              <a:t> world, the callback implementation is much more common.</a:t>
             </a:r>
           </a:p>
         </p:txBody>
@@ -13192,11 +13200,14 @@
           <a:lstStyle/>
           <a:p>
             <a:pPr algn="l"/>
-            <a:endParaRPr lang="en-US" dirty="0">
-              <a:solidFill>
-                <a:schemeClr val="tx1"/>
-              </a:solidFill>
-            </a:endParaRPr>
+            <a:r>
+              <a:rPr lang="en-US" dirty="0">
+                <a:solidFill>
+                  <a:schemeClr val="tx1"/>
+                </a:solidFill>
+              </a:rPr>
+              <a:t>"delegate" or "callback"</a:t>
+            </a:r>
           </a:p>
         </p:txBody>
       </p:sp>
@@ -18280,7 +18291,7 @@
           <a:p>
             <a:r>
               <a:rPr lang="en-US" dirty="0"/>
-              <a:t>This is called the Listener or Observer Pattern</a:t>
+              <a:t>This these are all instances of the Listener or Observer Pattern</a:t>
             </a:r>
           </a:p>
         </p:txBody>

</xml_diff>